<commit_message>
update on my part
</commit_message>
<xml_diff>
--- a/presentations/0616_Stablecoin_Exorbitant_Privilege.pptx
+++ b/presentations/0616_Stablecoin_Exorbitant_Privilege.pptx
@@ -12759,7 +12759,7 @@
         <p:spPr>
           <a:xfrm>
             <a:off x="1051560" y="2148840"/>
-            <a:ext cx="10149840" cy="1737360"/>
+            <a:ext cx="10149840" cy="1497330"/>
           </a:xfrm>
           <a:prstGeom prst="rect">
             <a:avLst/>
@@ -12812,7 +12812,25 @@
                 </a:solidFill>
                 <a:latin typeface="Georgia" panose="02040502050405090303"/>
               </a:rPr>
-              <a:t>Robust to controlling auction size and to removing all interpolated reserve controls, and it passes a 2,000-iteration placebo at 3 of 4 maturities (8/13/26-Week). At the individual-auction frequency the association is not detectable, consistent with stablecoin supply being a monthly-frequency variable.</a:t>
+              <a:t>Robust to controlling auction size and to removing all interpolated reserve controls, and it passes a 2,000-</a:t>
+            </a:r>
+            <a:r>
+              <a:rPr lang="en-US" altLang="en-US" sz="1450" b="0">
+                <a:solidFill>
+                  <a:srgbClr val="33425C"/>
+                </a:solidFill>
+                <a:latin typeface="Georgia" panose="02040502050405090303"/>
+              </a:rPr>
+              <a:t>shuffle </a:t>
+            </a:r>
+            <a:r>
+              <a:rPr sz="1450" b="0">
+                <a:solidFill>
+                  <a:srgbClr val="33425C"/>
+                </a:solidFill>
+                <a:latin typeface="Georgia" panose="02040502050405090303"/>
+              </a:rPr>
+              <a:t>placebo at 3 of 4 maturities (8/13/26-Week). At the individual-auction frequency the association is not detectable, consistent with stablecoin supply being a monthly-frequency variable.</a:t>
             </a:r>
             <a:endParaRPr sz="1450" b="0">
               <a:solidFill>

</xml_diff>

<commit_message>
update the regression model
</commit_message>
<xml_diff>
--- a/presentations/0616_Stablecoin_Exorbitant_Privilege.pptx
+++ b/presentations/0616_Stablecoin_Exorbitant_Privilege.pptx
@@ -15779,7 +15779,7 @@
         <p:spPr>
           <a:xfrm>
             <a:off x="822960" y="1911985"/>
-            <a:ext cx="10699750" cy="3308985"/>
+            <a:ext cx="5500000" cy="3308985"/>
           </a:xfrm>
           <a:prstGeom prst="rect">
             <a:avLst/>
@@ -15794,11 +15794,11 @@
           <a:p>
             <a:pPr algn="l">
               <a:spcAft>
-                <a:spcPts val="400"/>
-              </a:spcAft>
-            </a:pPr>
-            <a:r>
-              <a:rPr sz="1600" b="1">
+                <a:spcPts val="300"/>
+              </a:spcAft>
+            </a:pPr>
+            <a:r>
+              <a:rPr sz="1400" b="1">
                 <a:solidFill>
                   <a:srgbClr val="13294B"/>
                 </a:solidFill>
@@ -15806,7 +15806,7 @@
               </a:rPr>
               <a:t>β₁ — Privilege Amplification</a:t>
             </a:r>
-            <a:endParaRPr sz="1600" b="1">
+            <a:endParaRPr sz="1400" b="1">
               <a:solidFill>
                 <a:srgbClr val="13294B"/>
               </a:solidFill>
@@ -15820,7 +15820,7 @@
               </a:spcBef>
             </a:pPr>
             <a:r>
-              <a:rPr sz="1400" b="0">
+              <a:rPr sz="1200" b="0">
                 <a:solidFill>
                   <a:srgbClr val="33425C"/>
                 </a:solidFill>
@@ -15828,7 +15828,7 @@
               </a:rPr>
               <a:t>→  Measures the baseline direct effect of stablecoin supply growth on yield spreads, independent of the buffer level</a:t>
             </a:r>
-            <a:endParaRPr sz="1400" b="0">
+            <a:endParaRPr sz="1200" b="0">
               <a:solidFill>
                 <a:srgbClr val="33425C"/>
               </a:solidFill>
@@ -15838,7 +15838,7 @@
           <a:p>
             <a:pPr algn="l"/>
             <a:r>
-              <a:rPr sz="1400" b="0">
+              <a:rPr sz="1200" b="0">
                 <a:solidFill>
                   <a:srgbClr val="33425C"/>
                 </a:solidFill>
@@ -15846,7 +15846,7 @@
               </a:rPr>
               <a:t>→  Before: β₁ = −7.57 (p = 0.004) — statistically significant</a:t>
             </a:r>
-            <a:endParaRPr sz="1400" b="0">
+            <a:endParaRPr sz="1200" b="0">
               <a:solidFill>
                 <a:srgbClr val="33425C"/>
               </a:solidFill>
@@ -15856,7 +15856,7 @@
           <a:p>
             <a:pPr algn="l"/>
             <a:r>
-              <a:rPr sz="1400" b="1">
+              <a:rPr sz="1200" b="1">
                 <a:solidFill>
                   <a:srgbClr val="E8A12C"/>
                 </a:solidFill>
@@ -15864,7 +15864,7 @@
               </a:rPr>
               <a:t>→  After re-run: β₁ = +2.74 — not significant; sign flipped</a:t>
             </a:r>
-            <a:endParaRPr sz="1400" b="1">
+            <a:endParaRPr sz="1200" b="1">
               <a:solidFill>
                 <a:srgbClr val="E8A12C"/>
               </a:solidFill>
@@ -15878,7 +15878,7 @@
               </a:spcAft>
             </a:pPr>
             <a:r>
-              <a:rPr sz="1400" b="0">
+              <a:rPr sz="1200" b="0">
                 <a:solidFill>
                   <a:srgbClr val="33425C"/>
                 </a:solidFill>
@@ -15886,7 +15886,7 @@
               </a:rPr>
               <a:t>→  Verdict: amplification claim does not hold</a:t>
             </a:r>
-            <a:endParaRPr sz="1400" b="0">
+            <a:endParaRPr sz="1200" b="0">
               <a:solidFill>
                 <a:srgbClr val="33425C"/>
               </a:solidFill>
@@ -15896,30 +15896,14 @@
           <a:p>
             <a:pPr algn="l">
               <a:spcBef>
-                <a:spcPts val="1400"/>
+                <a:spcPts val="1200"/>
               </a:spcBef>
               <a:spcAft>
-                <a:spcPts val="400"/>
-              </a:spcAft>
-            </a:pPr>
-            <a:endParaRPr sz="1600" b="1">
-              <a:solidFill>
-                <a:srgbClr val="13294B"/>
-              </a:solidFill>
-              <a:latin typeface="Calibri"/>
-            </a:endParaRPr>
-          </a:p>
-          <a:p>
-            <a:pPr algn="l">
-              <a:spcBef>
-                <a:spcPts val="1400"/>
-              </a:spcBef>
-              <a:spcAft>
-                <a:spcPts val="400"/>
-              </a:spcAft>
-            </a:pPr>
-            <a:r>
-              <a:rPr sz="1600" b="1">
+                <a:spcPts val="300"/>
+              </a:spcAft>
+            </a:pPr>
+            <a:r>
+              <a:rPr sz="1400" b="1">
                 <a:solidFill>
                   <a:srgbClr val="13294B"/>
                 </a:solidFill>
@@ -15927,7 +15911,7 @@
               </a:rPr>
               <a:t>β₄ — Buffer Interaction</a:t>
             </a:r>
-            <a:endParaRPr sz="1600" b="1">
+            <a:endParaRPr sz="1400" b="1">
               <a:solidFill>
                 <a:srgbClr val="13294B"/>
               </a:solidFill>
@@ -15941,7 +15925,7 @@
               </a:spcBef>
             </a:pPr>
             <a:r>
-              <a:rPr sz="1400" b="0">
+              <a:rPr sz="1200" b="0">
                 <a:solidFill>
                   <a:srgbClr val="33425C"/>
                 </a:solidFill>
@@ -15949,7 +15933,7 @@
               </a:rPr>
               <a:t>→  Tests whether the reserve buffer level amplifies or dampens the effect of stablecoin supply growth on spreads</a:t>
             </a:r>
-            <a:endParaRPr sz="1400" b="0">
+            <a:endParaRPr sz="1200" b="0">
               <a:solidFill>
                 <a:srgbClr val="33425C"/>
               </a:solidFill>
@@ -15959,7 +15943,7 @@
           <a:p>
             <a:pPr algn="l"/>
             <a:r>
-              <a:rPr sz="1400" b="0">
+              <a:rPr sz="1200" b="0">
                 <a:solidFill>
                   <a:srgbClr val="33425C"/>
                 </a:solidFill>
@@ -15967,7 +15951,7 @@
               </a:rPr>
               <a:t>→  Levels regression: β₄ = −35.89 (p = 0.032) — appeared significant</a:t>
             </a:r>
-            <a:endParaRPr sz="1400" b="0">
+            <a:endParaRPr sz="1200" b="0">
               <a:solidFill>
                 <a:srgbClr val="33425C"/>
               </a:solidFill>
@@ -15977,7 +15961,7 @@
           <a:p>
             <a:pPr algn="l"/>
             <a:r>
-              <a:rPr sz="1400" b="1">
+              <a:rPr sz="1200" b="1">
                 <a:solidFill>
                   <a:srgbClr val="E8A12C"/>
                 </a:solidFill>
@@ -15985,7 +15969,7 @@
               </a:rPr>
               <a:t>→  First-differenced: β₄ = −107 (p = 0.46) — collapses to insignificance</a:t>
             </a:r>
-            <a:endParaRPr sz="1400" b="1">
+            <a:endParaRPr sz="1200" b="1">
               <a:solidFill>
                 <a:srgbClr val="E8A12C"/>
               </a:solidFill>
@@ -15995,7 +15979,7 @@
           <a:p>
             <a:pPr algn="l"/>
             <a:r>
-              <a:rPr sz="1400" b="0">
+              <a:rPr sz="1200" b="0">
                 <a:solidFill>
                   <a:srgbClr val="33425C"/>
                 </a:solidFill>
@@ -16003,7 +15987,7 @@
               </a:rPr>
               <a:t>→  Result vanishes under differencing — consistent with spurious regression</a:t>
             </a:r>
-            <a:endParaRPr sz="1400" b="0">
+            <a:endParaRPr sz="1200" b="0">
               <a:solidFill>
                 <a:srgbClr val="33425C"/>
               </a:solidFill>
@@ -16273,30 +16257,441 @@
           </a:p>
         </p:txBody>
       </p:sp>
-      <p:pic>
-        <p:nvPicPr>
-          <p:cNvPr id="11" name="Picture 10"/>
-          <p:cNvPicPr>
-            <a:picLocks noChangeAspect="1"/>
-          </p:cNvPicPr>
-          <p:nvPr/>
-        </p:nvPicPr>
-        <p:blipFill>
-          <a:blip r:embed="rId1"/>
-          <a:stretch>
-            <a:fillRect/>
-          </a:stretch>
-        </p:blipFill>
-        <p:spPr>
-          <a:xfrm>
-            <a:off x="6903720" y="2593975"/>
-            <a:ext cx="4601210" cy="1485265"/>
-          </a:xfrm>
-          <a:prstGeom prst="rect">
-            <a:avLst/>
-          </a:prstGeom>
-        </p:spPr>
-      </p:pic>
+      <p:sp>
+        <p:nvSpPr>
+          <p:cNvPr id="20" name="Rectangle 19"/>
+          <p:cNvSpPr/>
+          <p:nvPr/>
+        </p:nvSpPr>
+        <p:spPr>
+          <a:xfrm>
+            <a:off x="6422960" y="1960000"/>
+            <a:ext cx="55000" cy="970000"/>
+          </a:xfrm>
+          <a:prstGeom prst="rect">
+            <a:avLst/>
+          </a:prstGeom>
+          <a:solidFill>
+            <a:srgbClr val="13294B"/>
+          </a:solidFill>
+          <a:ln>
+            <a:noFill/>
+          </a:ln>
+        </p:spPr>
+        <p:style>
+          <a:lnRef idx="1">
+            <a:schemeClr val="accent1"/>
+          </a:lnRef>
+          <a:fillRef idx="3">
+            <a:schemeClr val="accent1"/>
+          </a:fillRef>
+          <a:effectRef idx="2">
+            <a:schemeClr val="accent1"/>
+          </a:effectRef>
+          <a:fontRef idx="minor">
+            <a:schemeClr val="lt1"/>
+          </a:fontRef>
+        </p:style>
+        <p:txBody>
+          <a:bodyPr rtlCol="0" anchor="ctr"/>
+          <a:lstStyle/>
+          <a:p>
+            <a:pPr algn="ctr"/>
+          </a:p>
+        </p:txBody>
+      </p:sp>
+      <p:sp>
+        <p:nvSpPr>
+          <p:cNvPr id="21" name="TextBox 20"/>
+          <p:cNvSpPr txBox="1"/>
+          <p:nvPr/>
+        </p:nvSpPr>
+        <p:spPr>
+          <a:xfrm>
+            <a:off x="6567960" y="2010000"/>
+            <a:ext cx="4912225" cy="934720"/>
+          </a:xfrm>
+          <a:prstGeom prst="rect">
+            <a:avLst/>
+          </a:prstGeom>
+          <a:noFill/>
+        </p:spPr>
+        <p:txBody>
+          <a:bodyPr wrap="square">
+            <a:spAutoFit/>
+          </a:bodyPr>
+          <a:lstStyle/>
+          <a:p>
+            <a:pPr algn="l">
+              <a:spcAft>
+                <a:spcPts val="500"/>
+              </a:spcAft>
+            </a:pPr>
+            <a:r>
+              <a:rPr sz="1050" b="1">
+                <a:solidFill>
+                  <a:srgbClr val="13294B"/>
+                </a:solidFill>
+                <a:latin typeface="Calibri"/>
+              </a:rPr>
+              <a:t>① Original  —  before professor's feedback</a:t>
+            </a:r>
+            <a:endParaRPr sz="1050" b="1">
+              <a:solidFill>
+                <a:srgbClr val="13294B"/>
+              </a:solidFill>
+              <a:latin typeface="Calibri"/>
+            </a:endParaRPr>
+          </a:p>
+          <a:p>
+            <a:pPr algn="l">
+              <a:spcAft>
+                <a:spcPts val="500"/>
+              </a:spcAft>
+            </a:pPr>
+            <a:r>
+              <a:rPr sz="1200" b="0">
+                <a:solidFill>
+                  <a:srgbClr val="33425C"/>
+                </a:solidFill>
+                <a:latin typeface="Calibri"/>
+              </a:rPr>
+              <a:t>Spread = α + β₁·ΔlnS + β₂·θ + β₃·L + β₄·(L×ΔlnS) + controls</a:t>
+            </a:r>
+            <a:endParaRPr sz="1200" b="0">
+              <a:solidFill>
+                <a:srgbClr val="33425C"/>
+              </a:solidFill>
+              <a:latin typeface="Calibri"/>
+            </a:endParaRPr>
+          </a:p>
+          <a:p>
+            <a:pPr algn="l"/>
+            <a:r>
+              <a:rPr sz="1200" b="1">
+                <a:solidFill>
+                  <a:srgbClr val="C1121F"/>
+                </a:solidFill>
+                <a:latin typeface="Calibri"/>
+              </a:rPr>
+              <a:t>β₁ = −7.57   (p = 0.004) ***</a:t>
+            </a:r>
+            <a:br>
+              <a:rPr sz="1200" b="1">
+                <a:solidFill>
+                  <a:srgbClr val="C1121F"/>
+                </a:solidFill>
+                <a:latin typeface="Calibri"/>
+              </a:rPr>
+            </a:br>
+            <a:endParaRPr sz="1200" b="1">
+              <a:solidFill>
+                <a:srgbClr val="C1121F"/>
+              </a:solidFill>
+              <a:latin typeface="Calibri"/>
+              <a:sym typeface="+mn-ea"/>
+            </a:endParaRPr>
+          </a:p>
+        </p:txBody>
+      </p:sp>
+      <p:sp>
+        <p:nvSpPr>
+          <p:cNvPr id="22" name="Rectangle 21"/>
+          <p:cNvSpPr/>
+          <p:nvPr/>
+        </p:nvSpPr>
+        <p:spPr>
+          <a:xfrm>
+            <a:off x="6422960" y="3060000"/>
+            <a:ext cx="55000" cy="1070000"/>
+          </a:xfrm>
+          <a:prstGeom prst="rect">
+            <a:avLst/>
+          </a:prstGeom>
+          <a:solidFill>
+            <a:srgbClr val="1B998B"/>
+          </a:solidFill>
+          <a:ln>
+            <a:noFill/>
+          </a:ln>
+        </p:spPr>
+        <p:style>
+          <a:lnRef idx="1">
+            <a:schemeClr val="accent1"/>
+          </a:lnRef>
+          <a:fillRef idx="3">
+            <a:schemeClr val="accent1"/>
+          </a:fillRef>
+          <a:effectRef idx="2">
+            <a:schemeClr val="accent1"/>
+          </a:effectRef>
+          <a:fontRef idx="minor">
+            <a:schemeClr val="lt1"/>
+          </a:fontRef>
+        </p:style>
+        <p:txBody>
+          <a:bodyPr rtlCol="0" anchor="ctr"/>
+          <a:lstStyle/>
+          <a:p>
+            <a:pPr algn="ctr"/>
+          </a:p>
+        </p:txBody>
+      </p:sp>
+      <p:sp>
+        <p:nvSpPr>
+          <p:cNvPr id="23" name="TextBox 22"/>
+          <p:cNvSpPr txBox="1"/>
+          <p:nvPr/>
+        </p:nvSpPr>
+        <p:spPr>
+          <a:xfrm>
+            <a:off x="6567960" y="3110000"/>
+            <a:ext cx="4912225" cy="973455"/>
+          </a:xfrm>
+          <a:prstGeom prst="rect">
+            <a:avLst/>
+          </a:prstGeom>
+          <a:noFill/>
+        </p:spPr>
+        <p:txBody>
+          <a:bodyPr wrap="square">
+            <a:spAutoFit/>
+          </a:bodyPr>
+          <a:lstStyle/>
+          <a:p>
+            <a:pPr algn="l">
+              <a:spcAft>
+                <a:spcPts val="500"/>
+              </a:spcAft>
+            </a:pPr>
+            <a:r>
+              <a:rPr sz="1050" b="1">
+                <a:solidFill>
+                  <a:srgbClr val="1B998B"/>
+                </a:solidFill>
+                <a:latin typeface="Calibri"/>
+              </a:rPr>
+              <a:t>② Corrected  —  θ dropped (θ+L≈1, collinear), L kept</a:t>
+            </a:r>
+            <a:endParaRPr sz="1050" b="1">
+              <a:solidFill>
+                <a:srgbClr val="1B998B"/>
+              </a:solidFill>
+              <a:latin typeface="Calibri"/>
+            </a:endParaRPr>
+          </a:p>
+          <a:p>
+            <a:pPr algn="l">
+              <a:spcAft>
+                <a:spcPts val="500"/>
+              </a:spcAft>
+            </a:pPr>
+            <a:r>
+              <a:rPr sz="1200" b="0">
+                <a:solidFill>
+                  <a:srgbClr val="33425C"/>
+                </a:solidFill>
+                <a:latin typeface="Calibri"/>
+              </a:rPr>
+              <a:t>Spread = α + β₁·ΔlnS + β₃·L + β₄·(L×ΔlnS) + controls</a:t>
+            </a:r>
+            <a:endParaRPr sz="1200" b="0">
+              <a:solidFill>
+                <a:srgbClr val="33425C"/>
+              </a:solidFill>
+              <a:latin typeface="Calibri"/>
+            </a:endParaRPr>
+          </a:p>
+          <a:p>
+            <a:pPr algn="l">
+              <a:spcAft>
+                <a:spcPts val="300"/>
+              </a:spcAft>
+            </a:pPr>
+            <a:r>
+              <a:rPr sz="1200" b="1">
+                <a:solidFill>
+                  <a:srgbClr val="E8A12C"/>
+                </a:solidFill>
+                <a:latin typeface="Calibri"/>
+              </a:rPr>
+              <a:t>β₁ = +2.74   (p = 0.228)   not significant</a:t>
+            </a:r>
+            <a:endParaRPr sz="1200" b="1">
+              <a:solidFill>
+                <a:srgbClr val="E8A12C"/>
+              </a:solidFill>
+              <a:latin typeface="Calibri"/>
+            </a:endParaRPr>
+          </a:p>
+          <a:p>
+            <a:pPr algn="l"/>
+            <a:r>
+              <a:rPr sz="1200" b="1">
+                <a:solidFill>
+                  <a:srgbClr val="E8A12C"/>
+                </a:solidFill>
+                <a:latin typeface="Calibri"/>
+              </a:rPr>
+              <a:t>β₄ = −35.89  (p = 0.032)   significant in levels</a:t>
+            </a:r>
+            <a:endParaRPr sz="1200" b="1">
+              <a:solidFill>
+                <a:srgbClr val="E8A12C"/>
+              </a:solidFill>
+              <a:latin typeface="Calibri"/>
+            </a:endParaRPr>
+          </a:p>
+        </p:txBody>
+      </p:sp>
+      <p:sp>
+        <p:nvSpPr>
+          <p:cNvPr id="24" name="Rectangle 23"/>
+          <p:cNvSpPr/>
+          <p:nvPr/>
+        </p:nvSpPr>
+        <p:spPr>
+          <a:xfrm>
+            <a:off x="6422960" y="4200000"/>
+            <a:ext cx="55000" cy="970000"/>
+          </a:xfrm>
+          <a:prstGeom prst="rect">
+            <a:avLst/>
+          </a:prstGeom>
+          <a:solidFill>
+            <a:srgbClr val="E8A12C"/>
+          </a:solidFill>
+          <a:ln>
+            <a:noFill/>
+          </a:ln>
+        </p:spPr>
+        <p:style>
+          <a:lnRef idx="1">
+            <a:schemeClr val="accent1"/>
+          </a:lnRef>
+          <a:fillRef idx="3">
+            <a:schemeClr val="accent1"/>
+          </a:fillRef>
+          <a:effectRef idx="2">
+            <a:schemeClr val="accent1"/>
+          </a:effectRef>
+          <a:fontRef idx="minor">
+            <a:schemeClr val="lt1"/>
+          </a:fontRef>
+        </p:style>
+        <p:txBody>
+          <a:bodyPr rtlCol="0" anchor="ctr"/>
+          <a:lstStyle/>
+          <a:p>
+            <a:pPr algn="ctr"/>
+          </a:p>
+        </p:txBody>
+      </p:sp>
+      <p:sp>
+        <p:nvSpPr>
+          <p:cNvPr id="25" name="TextBox 24"/>
+          <p:cNvSpPr txBox="1"/>
+          <p:nvPr/>
+        </p:nvSpPr>
+        <p:spPr>
+          <a:xfrm>
+            <a:off x="6567960" y="4250000"/>
+            <a:ext cx="4912225" cy="750570"/>
+          </a:xfrm>
+          <a:prstGeom prst="rect">
+            <a:avLst/>
+          </a:prstGeom>
+          <a:noFill/>
+        </p:spPr>
+        <p:txBody>
+          <a:bodyPr wrap="square">
+            <a:spAutoFit/>
+          </a:bodyPr>
+          <a:lstStyle/>
+          <a:p>
+            <a:pPr algn="l">
+              <a:spcAft>
+                <a:spcPts val="500"/>
+              </a:spcAft>
+            </a:pPr>
+            <a:r>
+              <a:rPr sz="1050" b="1">
+                <a:solidFill>
+                  <a:srgbClr val="E8A12C"/>
+                </a:solidFill>
+                <a:latin typeface="Calibri"/>
+              </a:rPr>
+              <a:t>③ First-differenced  —  L replaced by ΔL (removes drift)</a:t>
+            </a:r>
+            <a:endParaRPr sz="1050" b="1">
+              <a:solidFill>
+                <a:srgbClr val="E8A12C"/>
+              </a:solidFill>
+              <a:latin typeface="Calibri"/>
+            </a:endParaRPr>
+          </a:p>
+          <a:p>
+            <a:pPr algn="l">
+              <a:spcAft>
+                <a:spcPts val="500"/>
+              </a:spcAft>
+            </a:pPr>
+            <a:r>
+              <a:rPr sz="1200" b="0">
+                <a:solidFill>
+                  <a:srgbClr val="33425C"/>
+                </a:solidFill>
+                <a:latin typeface="Calibri"/>
+              </a:rPr>
+              <a:t>ΔSpread = α + β₁·Δ²lnS + β₃·ΔL + β₄·(ΔL×Δ²lnS) + controls</a:t>
+            </a:r>
+            <a:endParaRPr sz="1200" b="0">
+              <a:solidFill>
+                <a:srgbClr val="33425C"/>
+              </a:solidFill>
+              <a:latin typeface="Calibri"/>
+            </a:endParaRPr>
+          </a:p>
+          <a:p>
+            <a:pPr algn="l"/>
+            <a:r>
+              <a:rPr sz="1200" b="1">
+                <a:solidFill>
+                  <a:srgbClr val="C1121F"/>
+                </a:solidFill>
+                <a:latin typeface="Calibri"/>
+                <a:sym typeface="+mn-ea"/>
+              </a:rPr>
+              <a:t>β₁ = </a:t>
+            </a:r>
+            <a:r>
+              <a:rPr lang="en-US" altLang="en-US" sz="1200" b="1">
+                <a:solidFill>
+                  <a:srgbClr val="C1121F"/>
+                </a:solidFill>
+                <a:latin typeface="Calibri"/>
+                <a:sym typeface="+mn-ea"/>
+              </a:rPr>
+              <a:t>0.82 (p = 0.13)             </a:t>
+            </a:r>
+            <a:r>
+              <a:rPr sz="1200" b="1">
+                <a:solidFill>
+                  <a:srgbClr val="C1121F"/>
+                </a:solidFill>
+                <a:latin typeface="Calibri"/>
+              </a:rPr>
+              <a:t>β₄ = −107   (p = 0.46)  </a:t>
+            </a:r>
+            <a:endParaRPr lang="en-US" altLang="en-US" sz="1200" b="1">
+              <a:solidFill>
+                <a:srgbClr val="C1121F"/>
+              </a:solidFill>
+              <a:latin typeface="Calibri"/>
+            </a:endParaRPr>
+          </a:p>
+        </p:txBody>
+      </p:sp>
     </p:spTree>
   </p:cSld>
   <p:clrMapOvr>

</xml_diff>